<commit_message>
Refresh demo PPTX fixture with exact slide count
</commit_message>
<xml_diff>
--- a/internal/demoflow/testdata/launch-strategy-demo.officecli.pptx
+++ b/internal/demoflow/testdata/launch-strategy-demo.officecli.pptx
@@ -14,7 +14,6 @@
     <p:sldId id="262" r:id="rId8"/>
     <p:sldId id="263" r:id="rId9"/>
     <p:sldId id="264" r:id="rId10"/>
-    <p:sldId id="265" r:id="rId11"/>
   </p:sldIdLst>
   <p:sldSz cx="12192000" cy="6858000"/>
   <p:notesSz cx="6858000" cy="9144000"/>
@@ -209,7 +208,7 @@
                 <a:latin typeface="Aptos"/>
                 <a:ea typeface="Microsoft YaHei"/>
               </a:rPr>
-              <a:t>OfficeDex can win by turning fragmented daily office work into one AI-assisted workflow with measurable time savings and enterprise-ready control</a:t>
+              <a:t>OfficeDex can enter the market as a measurable productivity upgrade for distributed teams, not just another AI assistant</a:t>
             </a:r>
           </a:p>
         </p:txBody>
@@ -267,355 +266,7 @@
                   </a:srgbClr>
                 </a:solidFill>
               </a:rPr>
-              <a:t>01/10</a:t>
-            </a:r>
-          </a:p>
-        </p:txBody>
-      </p:sp>
-    </p:spTree>
-  </p:cSld>
-</p:sld>
-</file>
-
-<file path=ppt/slides/slide10.xml><?xml version="1.0" encoding="utf-8"?>
-<p:sld xmlns:a="http://schemas.openxmlformats.org/drawingml/2006/main" xmlns:r="http://schemas.openxmlformats.org/officeDocument/2006/relationships" xmlns:p="http://schemas.openxmlformats.org/presentationml/2006/main">
-  <p:cSld>
-    <p:bg>
-      <p:bgPr>
-        <a:solidFill>
-          <a:srgbClr val="0B1020"/>
-        </a:solidFill>
-        <a:effectLst/>
-      </p:bgPr>
-    </p:bg>
-    <p:spTree>
-      <p:nvGrpSpPr>
-        <p:cNvPr id="1" name=""/>
-        <p:cNvGrpSpPr/>
-        <p:nvPr/>
-      </p:nvGrpSpPr>
-      <p:grpSpPr>
-        <a:xfrm>
-          <a:off x="0" y="0"/>
-          <a:ext cx="0" cy="0"/>
-          <a:chOff x="0" y="0"/>
-          <a:chExt cx="0" cy="0"/>
-        </a:xfrm>
-      </p:grpSpPr>
-      <p:sp>
-        <p:nvSpPr>
-          <p:cNvPr id="2" name="Title"/>
-          <p:cNvSpPr/>
-          <p:nvPr/>
-        </p:nvSpPr>
-        <p:spPr>
-          <a:xfrm>
-            <a:off x="900000" y="250000"/>
-            <a:ext cx="10800000" cy="650000"/>
-          </a:xfrm>
-          <a:prstGeom prst="rect">
-            <a:avLst/>
-          </a:prstGeom>
-        </p:spPr>
-        <p:txBody>
-          <a:bodyPr anchor="b">
-            <a:normAutofit/>
-          </a:bodyPr>
-          <a:lstStyle/>
-          <a:p>
-            <a:pPr algn="l"/>
-            <a:r>
-              <a:rPr lang="zh-CN" sz="3200" b="1">
-                <a:solidFill>
-                  <a:srgbClr val="FFFFFF"/>
-                </a:solidFill>
-                <a:latin typeface="Aptos"/>
-                <a:ea typeface="Microsoft YaHei"/>
-              </a:rPr>
-              <a:t>Launch Success Metrics Dashboard</a:t>
-            </a:r>
-          </a:p>
-        </p:txBody>
-      </p:sp>
-      <p:sp>
-        <p:nvSpPr>
-          <p:cNvPr id="6" name="Subtitle"/>
-          <p:cNvSpPr/>
-          <p:nvPr/>
-        </p:nvSpPr>
-        <p:spPr>
-          <a:xfrm>
-            <a:off x="700000" y="900000"/>
-            <a:ext cx="10800000" cy="900000"/>
-          </a:xfrm>
-          <a:prstGeom prst="rect">
-            <a:avLst/>
-          </a:prstGeom>
-        </p:spPr>
-        <p:txBody>
-          <a:bodyPr anchor="t">
-            <a:normAutofit/>
-          </a:bodyPr>
-          <a:lstStyle/>
-          <a:p>
-            <a:pPr algn="l"/>
-            <a:r>
-              <a:rPr lang="zh-CN" sz="2000">
-                <a:solidFill>
-                  <a:srgbClr val="E5E7EB">
-                    <a:alpha val="80000"/>
-                  </a:srgbClr>
-                </a:solidFill>
-                <a:latin typeface="Aptos"/>
-                <a:ea typeface="Microsoft YaHei"/>
-              </a:rPr>
-              <a:t>The strongest launch signal is not raw sign-ups but sustained weekly usage paired with expansion-ready team adoption</a:t>
-            </a:r>
-          </a:p>
-        </p:txBody>
-      </p:sp>
-      <p:sp>
-        <p:nvSpPr>
-          <p:cNvPr id="40" name="ClosingDecisionBanner"/>
-          <p:cNvSpPr/>
-          <p:nvPr/>
-        </p:nvSpPr>
-        <p:spPr>
-          <a:xfrm>
-            <a:off x="1200000" y="1950000"/>
-            <a:ext cx="9800000" cy="1280000"/>
-          </a:xfrm>
-          <a:prstGeom prst="rect">
-            <a:avLst/>
-          </a:prstGeom>
-          <a:solidFill>
-            <a:srgbClr val="111827">
-              <a:alpha val="96000"/>
-            </a:srgbClr>
-          </a:solidFill>
-          <a:ln>
-            <a:noFill/>
-          </a:ln>
-        </p:spPr>
-      </p:sp>
-      <p:sp>
-        <p:nvSpPr>
-          <p:cNvPr id="41" name="ClosingDecisionAccent"/>
-          <p:cNvSpPr/>
-          <p:nvPr/>
-        </p:nvSpPr>
-        <p:spPr>
-          <a:xfrm>
-            <a:off x="1200000" y="1950000"/>
-            <a:ext cx="130000" cy="1280000"/>
-          </a:xfrm>
-          <a:prstGeom prst="rect">
-            <a:avLst/>
-          </a:prstGeom>
-          <a:solidFill>
-            <a:srgbClr val="F97316">
-              <a:alpha val="100000"/>
-            </a:srgbClr>
-          </a:solidFill>
-          <a:ln>
-            <a:noFill/>
-          </a:ln>
-        </p:spPr>
-      </p:sp>
-      <p:sp>
-        <p:nvSpPr>
-          <p:cNvPr id="42" name="ClosingDecisionHeading"/>
-          <p:cNvSpPr/>
-          <p:nvPr/>
-        </p:nvSpPr>
-        <p:spPr>
-          <a:xfrm>
-            <a:off x="1500000" y="2180000"/>
-            <a:ext cx="9200000" cy="360000"/>
-          </a:xfrm>
-          <a:prstGeom prst="rect">
-            <a:avLst/>
-          </a:prstGeom>
-        </p:spPr>
-        <p:txBody>
-          <a:bodyPr anchor="ctr">
-            <a:normAutofit/>
-          </a:bodyPr>
-          <a:lstStyle/>
-          <a:p>
-            <a:pPr algn="l"/>
-            <a:r>
-              <a:rPr lang="zh-CN" sz="1700" b="1">
-                <a:solidFill>
-                  <a:srgbClr val="FFFFFF"/>
-                </a:solidFill>
-                <a:latin typeface="Aptos"/>
-                <a:ea typeface="Microsoft YaHei"/>
-              </a:rPr>
-              <a:t>01</a:t>
-            </a:r>
-          </a:p>
-        </p:txBody>
-      </p:sp>
-      <p:sp>
-        <p:nvSpPr>
-          <p:cNvPr id="43" name="ClosingDecisionText"/>
-          <p:cNvSpPr/>
-          <p:nvPr/>
-        </p:nvSpPr>
-        <p:spPr>
-          <a:xfrm>
-            <a:off x="1500000" y="2650000"/>
-            <a:ext cx="9200000" cy="380000"/>
-          </a:xfrm>
-          <a:prstGeom prst="rect">
-            <a:avLst/>
-          </a:prstGeom>
-        </p:spPr>
-        <p:txBody>
-          <a:bodyPr anchor="t">
-            <a:normAutofit/>
-          </a:bodyPr>
-          <a:lstStyle/>
-          <a:p>
-            <a:pPr algn="l"/>
-            <a:r>
-              <a:rPr lang="zh-CN" sz="1450">
-                <a:solidFill>
-                  <a:srgbClr val="E5E7EB"/>
-                </a:solidFill>
-                <a:latin typeface="Aptos"/>
-                <a:ea typeface="Microsoft YaHei"/>
-              </a:rPr>
-              <a:t>Monitor time-to-value within.</a:t>
-            </a:r>
-          </a:p>
-        </p:txBody>
-      </p:sp>
-      <p:sp>
-        <p:nvSpPr>
-          <p:cNvPr id="50" name="ClosingDecisionSupportHead1"/>
-          <p:cNvSpPr/>
-          <p:nvPr/>
-        </p:nvSpPr>
-        <p:spPr>
-          <a:xfrm>
-            <a:off x="1500000" y="3720000"/>
-            <a:ext cx="3600000" cy="300000"/>
-          </a:xfrm>
-          <a:prstGeom prst="rect">
-            <a:avLst/>
-          </a:prstGeom>
-        </p:spPr>
-        <p:txBody>
-          <a:bodyPr anchor="ctr">
-            <a:normAutofit/>
-          </a:bodyPr>
-          <a:lstStyle/>
-          <a:p>
-            <a:pPr algn="l"/>
-            <a:r>
-              <a:rPr lang="zh-CN" sz="1350" b="1">
-                <a:solidFill>
-                  <a:srgbClr val="F97316"/>
-                </a:solidFill>
-                <a:latin typeface="Aptos"/>
-                <a:ea typeface="Microsoft YaHei"/>
-              </a:rPr>
-              <a:t>02</a:t>
-            </a:r>
-          </a:p>
-        </p:txBody>
-      </p:sp>
-      <p:sp>
-        <p:nvSpPr>
-          <p:cNvPr id="51" name="ClosingDecisionSupportText1"/>
-          <p:cNvSpPr/>
-          <p:nvPr/>
-        </p:nvSpPr>
-        <p:spPr>
-          <a:xfrm>
-            <a:off x="1500000" y="4130000"/>
-            <a:ext cx="3600000" cy="420000"/>
-          </a:xfrm>
-          <a:prstGeom prst="rect">
-            <a:avLst/>
-          </a:prstGeom>
-        </p:spPr>
-        <p:txBody>
-          <a:bodyPr anchor="t">
-            <a:normAutofit/>
-          </a:bodyPr>
-          <a:lstStyle/>
-          <a:p>
-            <a:pPr algn="l"/>
-            <a:r>
-              <a:rPr lang="zh-CN" sz="1200">
-                <a:solidFill>
-                  <a:srgbClr val="E5E7EB"/>
-                </a:solidFill>
-                <a:latin typeface="Aptos"/>
-                <a:ea typeface="Microsoft YaHei"/>
-              </a:rPr>
-              <a:t>Track team expansion separately.</a:t>
-            </a:r>
-          </a:p>
-        </p:txBody>
-      </p:sp>
-      <p:sp>
-        <p:nvSpPr>
-          <p:cNvPr id="150" name="FooterRule"/>
-          <p:cNvSpPr/>
-          <p:nvPr/>
-        </p:nvSpPr>
-        <p:spPr>
-          <a:xfrm>
-            <a:off x="500000" y="6200000"/>
-            <a:ext cx="11100000" cy="0"/>
-          </a:xfrm>
-          <a:prstGeom prst="line">
-            <a:avLst/>
-          </a:prstGeom>
-          <a:ln w="12700">
-            <a:solidFill>
-              <a:srgbClr val="F97316">
-                <a:alpha val="34000"/>
-              </a:srgbClr>
-            </a:solidFill>
-          </a:ln>
-        </p:spPr>
-      </p:sp>
-      <p:sp>
-        <p:nvSpPr>
-          <p:cNvPr id="152" name="PageNumber"/>
-          <p:cNvSpPr/>
-          <p:nvPr/>
-        </p:nvSpPr>
-        <p:spPr>
-          <a:xfrm>
-            <a:off x="10300000" y="6300000"/>
-            <a:ext cx="1200000" cy="260000"/>
-          </a:xfrm>
-          <a:prstGeom prst="rect">
-            <a:avLst/>
-          </a:prstGeom>
-        </p:spPr>
-        <p:txBody>
-          <a:bodyPr anchor="b">
-            <a:normAutofit/>
-          </a:bodyPr>
-          <a:lstStyle/>
-          <a:p>
-            <a:pPr algn="r"/>
-            <a:r>
-              <a:rPr lang="zh-CN" sz="900">
-                <a:solidFill>
-                  <a:srgbClr val="E5E7EB">
-                    <a:alpha val="56000"/>
-                  </a:srgbClr>
-                </a:solidFill>
-              </a:rPr>
-              <a:t>10/10</a:t>
+              <a:t>01/09</a:t>
             </a:r>
           </a:p>
         </p:txBody>
@@ -716,7 +367,7 @@
         <p:spPr>
           <a:xfrm>
             <a:off x="700000" y="980000"/>
-            <a:ext cx="10800000" cy="840000"/>
+            <a:ext cx="10800000" cy="900000"/>
           </a:xfrm>
           <a:prstGeom prst="rect">
             <a:avLst/>
@@ -739,7 +390,7 @@
                 <a:latin typeface="Aptos"/>
                 <a:ea typeface="Microsoft YaHei"/>
               </a:rPr>
-              <a:t>The launch case is strongest where teams lose time across repetitive writing.</a:t>
+              <a:t>The launch should focus on cost of fragmented work because wasted time is the clearest buying trigger for executive buyers</a:t>
             </a:r>
           </a:p>
         </p:txBody>
@@ -752,7 +403,7 @@
         </p:nvSpPr>
         <p:spPr>
           <a:xfrm>
-            <a:off x="700000" y="2250000"/>
+            <a:off x="700000" y="2280000"/>
             <a:ext cx="5290000" cy="3600000"/>
           </a:xfrm>
           <a:prstGeom prst="roundRect">
@@ -789,7 +440,7 @@
         </p:nvSpPr>
         <p:spPr>
           <a:xfrm>
-            <a:off x="700000" y="2470000"/>
+            <a:off x="700000" y="2500000"/>
             <a:ext cx="5290000" cy="3340000"/>
           </a:xfrm>
           <a:prstGeom prst="rect">
@@ -811,7 +462,7 @@
                 <a:latin typeface="Aptos"/>
                 <a:ea typeface="Microsoft YaHei"/>
               </a:rPr>
-              <a:t>🧩 Tool Fragmentation</a:t>
+              <a:t>🔄 Tool Switching Overload</a:t>
             </a:r>
           </a:p>
           <a:p>
@@ -828,7 +479,7 @@
                 <a:latin typeface="Aptos"/>
                 <a:ea typeface="Microsoft YaHei"/>
               </a:rPr>
-              <a:t>Knowledge workers switch across 6 to 9 apps each day.</a:t>
+              <a:t>Knowledge workers use 8 to 12 apps daily and lose.</a:t>
             </a:r>
           </a:p>
         </p:txBody>
@@ -841,7 +492,7 @@
         </p:nvSpPr>
         <p:spPr>
           <a:xfrm>
-            <a:off x="6210000" y="2250000"/>
+            <a:off x="6210000" y="2280000"/>
             <a:ext cx="5290000" cy="3600000"/>
           </a:xfrm>
           <a:prstGeom prst="roundRect">
@@ -878,7 +529,7 @@
         </p:nvSpPr>
         <p:spPr>
           <a:xfrm>
-            <a:off x="6210000" y="2470000"/>
+            <a:off x="6210000" y="2500000"/>
             <a:ext cx="5290000" cy="3340000"/>
           </a:xfrm>
           <a:prstGeom prst="rect">
@@ -900,7 +551,7 @@
                 <a:latin typeface="Aptos"/>
                 <a:ea typeface="Microsoft YaHei"/>
               </a:rPr>
-              <a:t>⏱️ Manual Work Overload</a:t>
+              <a:t>🧩 Unstructured Knowledge Loss</a:t>
             </a:r>
           </a:p>
           <a:p>
@@ -917,7 +568,7 @@
                 <a:latin typeface="Aptos"/>
                 <a:ea typeface="Microsoft YaHei"/>
               </a:rPr>
-              <a:t>Professionals still spend 2 to 3 hours per day on notes.</a:t>
+              <a:t>Roughly 30% of project information stays trapped in messages and personal notes, slowing onboarding and repeatable execution across teams</a:t>
             </a:r>
           </a:p>
         </p:txBody>
@@ -975,7 +626,7 @@
                   </a:srgbClr>
                 </a:solidFill>
               </a:rPr>
-              <a:t>02/10</a:t>
+              <a:t>02/09</a:t>
             </a:r>
           </a:p>
         </p:txBody>
@@ -1019,7 +670,7 @@
         <p:spPr>
           <a:xfrm>
             <a:off x="500000" y="350000"/>
-            <a:ext cx="80000" cy="960000"/>
+            <a:ext cx="80000" cy="660000"/>
           </a:xfrm>
           <a:prstGeom prst="rect">
             <a:avLst/>
@@ -1041,7 +692,7 @@
         <p:spPr>
           <a:xfrm>
             <a:off x="700000" y="300000"/>
-            <a:ext cx="10800000" cy="1160000"/>
+            <a:ext cx="10800000" cy="860000"/>
           </a:xfrm>
           <a:prstGeom prst="rect">
             <a:avLst/>
@@ -1062,7 +713,7 @@
                 <a:latin typeface="Aptos"/>
                 <a:ea typeface="Microsoft YaHei"/>
               </a:rPr>
-              <a:t>The Productivity Problem Is Large and Immediate (cont.)</a:t>
+              <a:t>The Productivity Gap Is Expensive (cont.)</a:t>
             </a:r>
           </a:p>
         </p:txBody>
@@ -1075,8 +726,8 @@
         </p:nvSpPr>
         <p:spPr>
           <a:xfrm>
-            <a:off x="700000" y="1520000"/>
-            <a:ext cx="10800000" cy="840000"/>
+            <a:off x="700000" y="1220000"/>
+            <a:ext cx="10800000" cy="900000"/>
           </a:xfrm>
           <a:prstGeom prst="rect">
             <a:avLst/>
@@ -1099,7 +750,7 @@
                 <a:latin typeface="Aptos"/>
                 <a:ea typeface="Microsoft YaHei"/>
               </a:rPr>
-              <a:t>The launch case is strongest where teams lose time across repetitive writing.</a:t>
+              <a:t>The launch should focus on cost of fragmented work because wasted time is the clearest buying trigger for executive buyers</a:t>
             </a:r>
           </a:p>
         </p:txBody>
@@ -1112,7 +763,7 @@
         </p:nvSpPr>
         <p:spPr>
           <a:xfrm>
-            <a:off x="700000" y="3120000"/>
+            <a:off x="700000" y="3000000"/>
             <a:ext cx="5290000" cy="2400000"/>
           </a:xfrm>
           <a:prstGeom prst="roundRect">
@@ -1149,7 +800,7 @@
         </p:nvSpPr>
         <p:spPr>
           <a:xfrm>
-            <a:off x="900000" y="3320000"/>
+            <a:off x="900000" y="3200000"/>
             <a:ext cx="380000" cy="380000"/>
           </a:xfrm>
           <a:prstGeom prst="ellipse">
@@ -1177,7 +828,7 @@
                 <a:latin typeface="Aptos"/>
                 <a:ea typeface="Microsoft YaHei"/>
               </a:rPr>
-              <a:t>🔎</a:t>
+              <a:t>🤖</a:t>
             </a:r>
           </a:p>
         </p:txBody>
@@ -1190,7 +841,7 @@
         </p:nvSpPr>
         <p:spPr>
           <a:xfrm>
-            <a:off x="1360000" y="3320000"/>
+            <a:off x="1360000" y="3200000"/>
             <a:ext cx="4430000" cy="400000"/>
           </a:xfrm>
           <a:prstGeom prst="rect">
@@ -1212,7 +863,7 @@
                 <a:latin typeface="Aptos"/>
                 <a:ea typeface="Microsoft YaHei"/>
               </a:rPr>
-              <a:t>Search Friction</a:t>
+              <a:t>AI Adoption Friction</a:t>
             </a:r>
           </a:p>
         </p:txBody>
@@ -1225,7 +876,7 @@
         </p:nvSpPr>
         <p:spPr>
           <a:xfrm>
-            <a:off x="900000" y="3800000"/>
+            <a:off x="900000" y="3680000"/>
             <a:ext cx="4890000" cy="1520000"/>
           </a:xfrm>
           <a:prstGeom prst="rect">
@@ -1247,7 +898,7 @@
                 <a:latin typeface="Aptos"/>
                 <a:ea typeface="Microsoft YaHei"/>
               </a:rPr>
-              <a:t>Employees often need 10 to 15 minutes to locate the right version of a file, decision note, or customer update, delaying decisions and execution</a:t>
+              <a:t>More than 50% of teams test AI tools.</a:t>
             </a:r>
           </a:p>
         </p:txBody>
@@ -1305,7 +956,7 @@
                   </a:srgbClr>
                 </a:solidFill>
               </a:rPr>
-              <a:t>03/10</a:t>
+              <a:t>03/09</a:t>
             </a:r>
           </a:p>
         </p:txBody>
@@ -1392,7 +1043,7 @@
                 <a:latin typeface="Aptos"/>
                 <a:ea typeface="Microsoft YaHei"/>
               </a:rPr>
-              <a:t>Primary Audience Segments</a:t>
+              <a:t>Primary Audience and Buying Roles</a:t>
             </a:r>
           </a:p>
         </p:txBody>
@@ -1406,7 +1057,7 @@
         <p:spPr>
           <a:xfrm>
             <a:off x="700000" y="1220000"/>
-            <a:ext cx="10800000" cy="840000"/>
+            <a:ext cx="10800000" cy="900000"/>
           </a:xfrm>
           <a:prstGeom prst="rect">
             <a:avLst/>
@@ -1429,7 +1080,7 @@
                 <a:latin typeface="Aptos"/>
                 <a:ea typeface="Microsoft YaHei"/>
               </a:rPr>
-              <a:t>The best initial users are cross-functional teams with high communication volume.</a:t>
+              <a:t>OfficeDex should sell first to teams with high information velocity and visible coordination pain, while messaging differently to users and buyers</a:t>
             </a:r>
           </a:p>
         </p:txBody>
@@ -1442,8 +1093,8 @@
         </p:nvSpPr>
         <p:spPr>
           <a:xfrm>
-            <a:off x="700000" y="2240000"/>
-            <a:ext cx="10800000" cy="760000"/>
+            <a:off x="700000" y="2300000"/>
+            <a:ext cx="10800000" cy="940000"/>
           </a:xfrm>
           <a:prstGeom prst="roundRect">
             <a:avLst>
@@ -1479,7 +1130,7 @@
         </p:nvSpPr>
         <p:spPr>
           <a:xfrm>
-            <a:off x="920000" y="2410000"/>
+            <a:off x="920000" y="2470000"/>
             <a:ext cx="10360000" cy="420000"/>
           </a:xfrm>
           <a:prstGeom prst="rect">
@@ -1494,14 +1145,14 @@
           <a:p>
             <a:pPr algn="l"/>
             <a:r>
-              <a:rPr lang="zh-CN" sz="2200" b="1">
+              <a:rPr lang="zh-CN" sz="1900" b="1">
                 <a:solidFill>
                   <a:srgbClr val="E5E7EB"/>
                 </a:solidFill>
                 <a:latin typeface="Aptos"/>
                 <a:ea typeface="Microsoft YaHei"/>
               </a:rPr>
-              <a:t>Managers and Team Leads：They need faster meeting summaries.</a:t>
+              <a:t>Operations Leaders：COOs and operations heads need standardized workflows.</a:t>
             </a:r>
           </a:p>
         </p:txBody>
@@ -1514,8 +1165,8 @@
         </p:nvSpPr>
         <p:spPr>
           <a:xfrm>
-            <a:off x="700000" y="3220000"/>
-            <a:ext cx="10800000" cy="2880000"/>
+            <a:off x="700000" y="3460000"/>
+            <a:ext cx="10800000" cy="2640000"/>
           </a:xfrm>
           <a:prstGeom prst="rect">
             <a:avLst/>
@@ -1542,7 +1193,7 @@
                 <a:latin typeface="Aptos"/>
                 <a:ea typeface="Microsoft YaHei"/>
               </a:rPr>
-              <a:t>Sales and Customer Success：They benefit from account briefs.</a:t>
+              <a:t>Department Managers：Marketing, sales, and customer success managers want AI.</a:t>
             </a:r>
           </a:p>
         </p:txBody>
@@ -1600,7 +1251,7 @@
                   </a:srgbClr>
                 </a:solidFill>
               </a:rPr>
-              <a:t>04/10</a:t>
+              <a:t>04/09</a:t>
             </a:r>
           </a:p>
         </p:txBody>
@@ -1680,14 +1331,14 @@
           <a:p>
             <a:pPr algn="l"/>
             <a:r>
-              <a:rPr lang="zh-CN" sz="2800" b="1">
+              <a:rPr lang="zh-CN" sz="2500" b="1">
                 <a:solidFill>
                   <a:srgbClr val="FFFFFF"/>
                 </a:solidFill>
                 <a:latin typeface="Aptos"/>
                 <a:ea typeface="Microsoft YaHei"/>
               </a:rPr>
-              <a:t>Primary Audience Segments (cont.)</a:t>
+              <a:t>Primary Audience and Buying Roles (cont.)</a:t>
             </a:r>
           </a:p>
         </p:txBody>
@@ -1701,7 +1352,7 @@
         <p:spPr>
           <a:xfrm>
             <a:off x="700000" y="1220000"/>
-            <a:ext cx="10800000" cy="840000"/>
+            <a:ext cx="10800000" cy="900000"/>
           </a:xfrm>
           <a:prstGeom prst="rect">
             <a:avLst/>
@@ -1724,7 +1375,7 @@
                 <a:latin typeface="Aptos"/>
                 <a:ea typeface="Microsoft YaHei"/>
               </a:rPr>
-              <a:t>The best initial users are cross-functional teams with high communication volume.</a:t>
+              <a:t>OfficeDex should sell first to teams with high information velocity and visible coordination pain, while messaging differently to users and buyers</a:t>
             </a:r>
           </a:p>
         </p:txBody>
@@ -1737,8 +1388,8 @@
         </p:nvSpPr>
         <p:spPr>
           <a:xfrm>
-            <a:off x="700000" y="2240000"/>
-            <a:ext cx="10800000" cy="1140000"/>
+            <a:off x="700000" y="2300000"/>
+            <a:ext cx="10800000" cy="1120000"/>
           </a:xfrm>
           <a:prstGeom prst="roundRect">
             <a:avLst>
@@ -1780,7 +1431,7 @@
                 <a:latin typeface="Aptos"/>
                 <a:ea typeface="Microsoft YaHei"/>
               </a:rPr>
-              <a:t>Generic AI Assistants.</a:t>
+              <a:t>Generic AI Chat Tools.</a:t>
             </a:r>
           </a:p>
         </p:txBody>
@@ -1793,8 +1444,8 @@
         </p:nvSpPr>
         <p:spPr>
           <a:xfrm>
-            <a:off x="700000" y="3600000"/>
-            <a:ext cx="10800000" cy="1140000"/>
+            <a:off x="700000" y="3640000"/>
+            <a:ext cx="10800000" cy="1120000"/>
           </a:xfrm>
           <a:prstGeom prst="roundRect">
             <a:avLst>
@@ -1849,8 +1500,8 @@
         </p:nvSpPr>
         <p:spPr>
           <a:xfrm>
-            <a:off x="700000" y="4960000"/>
-            <a:ext cx="10800000" cy="1140000"/>
+            <a:off x="700000" y="4980000"/>
+            <a:ext cx="10800000" cy="1120000"/>
           </a:xfrm>
           <a:prstGeom prst="roundRect">
             <a:avLst>
@@ -1892,7 +1543,7 @@
                 <a:latin typeface="Aptos"/>
                 <a:ea typeface="Microsoft YaHei"/>
               </a:rPr>
-              <a:t>OfficeDex Advantage: Combines AI drafting, meeting intelligence, file search, and team workflows in one workspace designed to save 20% to 30% of weekly admin time</a:t>
+              <a:t>OfficeDex Position: Combines summarization, task orchestration, searchable memory, and workflow automation in one layer that can cut admin work by 35% to 50%</a:t>
             </a:r>
           </a:p>
         </p:txBody>
@@ -1950,7 +1601,7 @@
                   </a:srgbClr>
                 </a:solidFill>
               </a:rPr>
-              <a:t>05/10</a:t>
+              <a:t>05/09</a:t>
             </a:r>
           </a:p>
         </p:txBody>
@@ -2015,7 +1666,7 @@
                 <a:latin typeface="Aptos"/>
                 <a:ea typeface="Microsoft YaHei"/>
               </a:rPr>
-              <a:t>OfficeDex Positioning in the Market</a:t>
+              <a:t>Positioning: AI Work Orchestration, Not Generic Assistance</a:t>
             </a:r>
           </a:p>
         </p:txBody>
@@ -2029,7 +1680,7 @@
         <p:spPr>
           <a:xfrm>
             <a:off x="700000" y="900000"/>
-            <a:ext cx="10800000" cy="840000"/>
+            <a:ext cx="10800000" cy="900000"/>
           </a:xfrm>
           <a:prstGeom prst="rect">
             <a:avLst/>
@@ -2052,7 +1703,7 @@
                 <a:latin typeface="Aptos"/>
                 <a:ea typeface="Microsoft YaHei"/>
               </a:rPr>
-              <a:t>OfficeDex should be positioned as an execution layer for daily work.</a:t>
+              <a:t>OfficeDex stands out when positioned as a workflow layer that turns scattered work into action, ownership, and measurable output</a:t>
             </a:r>
           </a:p>
         </p:txBody>
@@ -2159,7 +1810,7 @@
                 <a:latin typeface="Aptos"/>
                 <a:ea typeface="Microsoft YaHei"/>
               </a:rPr>
-              <a:t>Generic AI Assistants.</a:t>
+              <a:t>Generic AI Chat Tools.</a:t>
             </a:r>
           </a:p>
         </p:txBody>
@@ -2373,7 +2024,7 @@
                 <a:latin typeface="Aptos"/>
                 <a:ea typeface="Microsoft YaHei"/>
               </a:rPr>
-              <a:t>OfficeDex Advantage: Combines AI drafting, meeting intelligence, file search, and team workflows in one workspace designed to save 20% to 30% of weekly admin time</a:t>
+              <a:t>OfficeDex Position: Combines summarization, task orchestration, searchable memory, and workflow automation in one layer that can cut admin work by 35% to 50%</a:t>
             </a:r>
           </a:p>
         </p:txBody>
@@ -2431,7 +2082,7 @@
                   </a:srgbClr>
                 </a:solidFill>
               </a:rPr>
-              <a:t>06/10</a:t>
+              <a:t>06/09</a:t>
             </a:r>
           </a:p>
         </p:txBody>
@@ -2475,7 +2126,7 @@
         <p:spPr>
           <a:xfrm>
             <a:off x="500000" y="350000"/>
-            <a:ext cx="80000" cy="660000"/>
+            <a:ext cx="80000" cy="960000"/>
           </a:xfrm>
           <a:prstGeom prst="rect">
             <a:avLst/>
@@ -2497,7 +2148,7 @@
         <p:spPr>
           <a:xfrm>
             <a:off x="700000" y="300000"/>
-            <a:ext cx="10800000" cy="860000"/>
+            <a:ext cx="10800000" cy="1160000"/>
           </a:xfrm>
           <a:prstGeom prst="rect">
             <a:avLst/>
@@ -2511,14 +2162,14 @@
           <a:p>
             <a:pPr algn="l"/>
             <a:r>
-              <a:rPr lang="zh-CN" sz="2800" b="1">
+              <a:rPr lang="zh-CN" sz="2500" b="1">
                 <a:solidFill>
                   <a:srgbClr val="FFFFFF"/>
                 </a:solidFill>
                 <a:latin typeface="Aptos"/>
                 <a:ea typeface="Microsoft YaHei"/>
               </a:rPr>
-              <a:t>Launch Channels and Demand Engine</a:t>
+              <a:t>Launch Channels to Build Awareness and Pipeline</a:t>
             </a:r>
           </a:p>
         </p:txBody>
@@ -2531,7 +2182,7 @@
         </p:nvSpPr>
         <p:spPr>
           <a:xfrm>
-            <a:off x="700000" y="1220000"/>
+            <a:off x="700000" y="1520000"/>
             <a:ext cx="10800000" cy="900000"/>
           </a:xfrm>
           <a:prstGeom prst="rect">
@@ -2555,7 +2206,7 @@
                 <a:latin typeface="Aptos"/>
                 <a:ea typeface="Microsoft YaHei"/>
               </a:rPr>
-              <a:t>A focused mix of product-led trial, expert content, and partner credibility will generate faster trust than broad paid awareness alone</a:t>
+              <a:t>A blended channel model will outperform a single-channel launch because OfficeDex must educate users while proving ROI to buyers</a:t>
             </a:r>
           </a:p>
         </p:txBody>
@@ -2568,8 +2219,8 @@
         </p:nvSpPr>
         <p:spPr>
           <a:xfrm>
-            <a:off x="700000" y="2300000"/>
-            <a:ext cx="4320000" cy="3800000"/>
+            <a:off x="700000" y="2600000"/>
+            <a:ext cx="4320000" cy="3500000"/>
           </a:xfrm>
           <a:prstGeom prst="roundRect">
             <a:avLst>
@@ -2605,8 +2256,8 @@
         </p:nvSpPr>
         <p:spPr>
           <a:xfrm>
-            <a:off x="820000" y="2560000"/>
-            <a:ext cx="4080000" cy="3280000"/>
+            <a:off x="820000" y="2860000"/>
+            <a:ext cx="4080000" cy="2980000"/>
           </a:xfrm>
           <a:prstGeom prst="rect">
             <a:avLst/>
@@ -2640,8 +2291,8 @@
         </p:nvSpPr>
         <p:spPr>
           <a:xfrm>
-            <a:off x="5240000" y="2300000"/>
-            <a:ext cx="6260000" cy="3800000"/>
+            <a:off x="5240000" y="2600000"/>
+            <a:ext cx="6260000" cy="3500000"/>
           </a:xfrm>
           <a:prstGeom prst="rect">
             <a:avLst/>
@@ -2668,7 +2319,7 @@
                 <a:latin typeface="Aptos"/>
                 <a:ea typeface="Microsoft YaHei"/>
               </a:rPr>
-              <a:t>Content and thought leadership.</a:t>
+              <a:t>Performance marketing.</a:t>
             </a:r>
           </a:p>
           <a:p>
@@ -2687,7 +2338,26 @@
                 <a:latin typeface="Aptos"/>
                 <a:ea typeface="Microsoft YaHei"/>
               </a:rPr>
-              <a:t>Executive and enterprise outreach: run account-based campaigns for operations, sales enablement, and mid-market IT leaders with ROI calculators and security briefs</a:t>
+              <a:t>Partner and community motion.</a:t>
+            </a:r>
+          </a:p>
+          <a:p>
+            <a:pPr marL="342900" indent="-342900" algn="l">
+              <a:spcBef>
+                <a:spcPts val="1100"/>
+              </a:spcBef>
+              <a:buFont typeface="Arial"/>
+              <a:buChar char="●"/>
+            </a:pPr>
+            <a:r>
+              <a:rPr lang="zh-CN" sz="2200">
+                <a:solidFill>
+                  <a:srgbClr val="E5E7EB"/>
+                </a:solidFill>
+                <a:latin typeface="Aptos"/>
+                <a:ea typeface="Microsoft YaHei"/>
+              </a:rPr>
+              <a:t>Executive proof content.</a:t>
             </a:r>
           </a:p>
         </p:txBody>
@@ -2745,7 +2415,7 @@
                   </a:srgbClr>
                 </a:solidFill>
               </a:rPr>
-              <a:t>07/10</a:t>
+              <a:t>07/09</a:t>
             </a:r>
           </a:p>
         </p:txBody>
@@ -2756,7 +2426,7 @@
 </file>
 
 <file path=ppt/slides/slide8.xml><?xml version="1.0" encoding="utf-8"?>
-<p:sld xmlns:a="http://schemas.openxmlformats.org/drawingml/2006/main" xmlns:r="http://schemas.openxmlformats.org/officeDocument/2006/relationships" xmlns:p="http://schemas.openxmlformats.org/presentationml/2006/main">
+<p:sld xmlns:a="http://schemas.openxmlformats.org/drawingml/2006/main" xmlns:r="http://schemas.openxmlformats.org/officeDocument/2006/relationships" xmlns:p="http://schemas.openxmlformats.org/presentationml/2006/main" xmlns:c="http://schemas.openxmlformats.org/drawingml/2006/chart">
   <p:cSld>
     <p:bg>
       <p:bgPr>
@@ -2782,14 +2452,36 @@
       </p:grpSpPr>
       <p:sp>
         <p:nvSpPr>
+          <p:cNvPr id="50" name="TitleDeco"/>
+          <p:cNvSpPr/>
+          <p:nvPr/>
+        </p:nvSpPr>
+        <p:spPr>
+          <a:xfrm>
+            <a:off x="500000" y="200000"/>
+            <a:ext cx="80000" cy="450000"/>
+          </a:xfrm>
+          <a:prstGeom prst="rect">
+            <a:avLst/>
+          </a:prstGeom>
+          <a:solidFill>
+            <a:srgbClr val="F97316"/>
+          </a:solidFill>
+          <a:ln>
+            <a:noFill/>
+          </a:ln>
+        </p:spPr>
+      </p:sp>
+      <p:sp>
+        <p:nvSpPr>
           <p:cNvPr id="2" name="Title"/>
           <p:cNvSpPr/>
           <p:nvPr/>
         </p:nvSpPr>
         <p:spPr>
           <a:xfrm>
-            <a:off x="900000" y="250000"/>
-            <a:ext cx="10800000" cy="650000"/>
+            <a:off x="700000" y="180000"/>
+            <a:ext cx="10800000" cy="520000"/>
           </a:xfrm>
           <a:prstGeom prst="rect">
             <a:avLst/>
@@ -2803,28 +2495,28 @@
           <a:p>
             <a:pPr algn="l"/>
             <a:r>
-              <a:rPr lang="zh-CN" sz="3200" b="1">
+              <a:rPr lang="zh-CN" sz="2800" b="1">
                 <a:solidFill>
                   <a:srgbClr val="FFFFFF"/>
                 </a:solidFill>
                 <a:latin typeface="Aptos"/>
                 <a:ea typeface="Microsoft YaHei"/>
               </a:rPr>
-              <a:t>Launch Channels and Demand Engine (cont.)</a:t>
-            </a:r>
-          </a:p>
-        </p:txBody>
-      </p:sp>
-      <p:sp>
-        <p:nvSpPr>
-          <p:cNvPr id="6" name="Subtitle"/>
-          <p:cNvSpPr/>
-          <p:nvPr/>
-        </p:nvSpPr>
-        <p:spPr>
-          <a:xfrm>
-            <a:off x="700000" y="900000"/>
-            <a:ext cx="10800000" cy="900000"/>
+              <a:t>90-Day Rollout Timeline</a:t>
+            </a:r>
+          </a:p>
+        </p:txBody>
+      </p:sp>
+      <p:sp>
+        <p:nvSpPr>
+          <p:cNvPr id="55" name="Subtitle"/>
+          <p:cNvSpPr/>
+          <p:nvPr/>
+        </p:nvSpPr>
+        <p:spPr>
+          <a:xfrm>
+            <a:off x="700000" y="770000"/>
+            <a:ext cx="10800000" cy="600000"/>
           </a:xfrm>
           <a:prstGeom prst="rect">
             <a:avLst/>
@@ -2847,25 +2539,25 @@
                 <a:latin typeface="Aptos"/>
                 <a:ea typeface="Microsoft YaHei"/>
               </a:rPr>
-              <a:t>A focused mix of product-led trial, expert content, and partner credibility will generate faster trust than broad paid awareness alone</a:t>
-            </a:r>
-          </a:p>
-        </p:txBody>
-      </p:sp>
-      <p:sp>
-        <p:nvSpPr>
-          <p:cNvPr id="40" name="CompareSpotlightPanel1"/>
-          <p:cNvSpPr/>
-          <p:nvPr/>
-        </p:nvSpPr>
-        <p:spPr>
-          <a:xfrm>
-            <a:off x="900000" y="1700000"/>
-            <a:ext cx="5600000" cy="3100000"/>
+              <a:t>The first 90 days should prioritize proof.</a:t>
+            </a:r>
+          </a:p>
+        </p:txBody>
+      </p:sp>
+      <p:sp>
+        <p:nvSpPr>
+          <p:cNvPr id="20" name="MetricBg0"/>
+          <p:cNvSpPr/>
+          <p:nvPr/>
+        </p:nvSpPr>
+        <p:spPr>
+          <a:xfrm>
+            <a:off x="700000" y="1550000"/>
+            <a:ext cx="3500000" cy="1020000"/>
           </a:xfrm>
           <a:prstGeom prst="roundRect">
             <a:avLst>
-              <a:gd name="adj" fmla="val 4000"/>
+              <a:gd name="adj" fmla="val 5000"/>
             </a:avLst>
           </a:prstGeom>
           <a:solidFill>
@@ -2873,106 +2565,94 @@
               <a:alpha val="9000"/>
             </a:srgbClr>
           </a:solidFill>
-          <a:ln w="12700">
+          <a:ln w="9525">
             <a:solidFill>
               <a:srgbClr val="F97316">
-                <a:alpha val="12000"/>
+                <a:alpha val="18000"/>
               </a:srgbClr>
             </a:solidFill>
           </a:ln>
-          <a:effectLst>
-            <a:outerShdw blurRad="101600" dist="38100" dir="2700000" algn="bl" rotWithShape="0">
-              <a:srgbClr val="000000">
-                <a:alpha val="12000"/>
-              </a:srgbClr>
-            </a:outerShdw>
-          </a:effectLst>
-        </p:spPr>
-      </p:sp>
-      <p:sp>
-        <p:nvSpPr>
-          <p:cNvPr id="41" name="CompareSpotlightHeader1"/>
-          <p:cNvSpPr/>
-          <p:nvPr/>
-        </p:nvSpPr>
-        <p:spPr>
-          <a:xfrm>
-            <a:off x="1080000" y="1880000"/>
-            <a:ext cx="5240000" cy="420000"/>
-          </a:xfrm>
-          <a:prstGeom prst="rect">
-            <a:avLst/>
-          </a:prstGeom>
-        </p:spPr>
-        <p:txBody>
-          <a:bodyPr anchor="ctr">
-            <a:normAutofit/>
-          </a:bodyPr>
-          <a:lstStyle/>
-          <a:p>
-            <a:pPr algn="l"/>
-            <a:r>
-              <a:rPr lang="zh-CN" sz="2200" b="1">
-                <a:solidFill>
-                  <a:srgbClr val="F97316"/>
-                </a:solidFill>
-                <a:latin typeface="Aptos"/>
-                <a:ea typeface="Microsoft YaHei"/>
-              </a:rPr>
-              <a:t>Days 1-30: Validate</a:t>
-            </a:r>
-          </a:p>
-        </p:txBody>
-      </p:sp>
-      <p:sp>
-        <p:nvSpPr>
-          <p:cNvPr id="42" name="CompareSpotlightDetail1"/>
-          <p:cNvSpPr/>
-          <p:nvPr/>
-        </p:nvSpPr>
-        <p:spPr>
-          <a:xfrm>
-            <a:off x="1080000" y="2420000"/>
-            <a:ext cx="5240000" cy="2200000"/>
-          </a:xfrm>
-          <a:prstGeom prst="rect">
-            <a:avLst/>
-          </a:prstGeom>
-        </p:spPr>
-        <p:txBody>
-          <a:bodyPr anchor="t" lIns="180000" rIns="180000">
-            <a:normAutofit/>
-          </a:bodyPr>
-          <a:lstStyle/>
-          <a:p>
-            <a:pPr algn="l"/>
-            <a:r>
-              <a:rPr lang="zh-CN" sz="1550">
-                <a:solidFill>
-                  <a:srgbClr val="E5E7EB"/>
-                </a:solidFill>
-                <a:latin typeface="Aptos"/>
-                <a:ea typeface="Microsoft YaHei"/>
-              </a:rPr>
-              <a:t>Owner: Product and Growth. Launch beta onboarding</a:t>
-            </a:r>
-          </a:p>
-        </p:txBody>
-      </p:sp>
-      <p:sp>
-        <p:nvSpPr>
-          <p:cNvPr id="43" name="CompareSpotlightPanel2"/>
-          <p:cNvSpPr/>
-          <p:nvPr/>
-        </p:nvSpPr>
-        <p:spPr>
-          <a:xfrm>
-            <a:off x="6900000" y="1700000"/>
-            <a:ext cx="3400000" cy="1450000"/>
+        </p:spPr>
+      </p:sp>
+      <p:sp>
+        <p:nvSpPr>
+          <p:cNvPr id="21" name="MetricText0"/>
+          <p:cNvSpPr/>
+          <p:nvPr/>
+        </p:nvSpPr>
+        <p:spPr>
+          <a:xfrm>
+            <a:off x="700000" y="1550000"/>
+            <a:ext cx="3500000" cy="1020000"/>
+          </a:xfrm>
+          <a:prstGeom prst="rect">
+            <a:avLst/>
+          </a:prstGeom>
+        </p:spPr>
+        <p:txBody>
+          <a:bodyPr anchor="ctr" lIns="72000" tIns="100000" rIns="72000" bIns="60000">
+            <a:normAutofit/>
+          </a:bodyPr>
+          <a:lstStyle/>
+          <a:p>
+            <a:pPr algn="ctr"/>
+            <a:r>
+              <a:rPr lang="zh-CN" sz="1020">
+                <a:solidFill>
+                  <a:srgbClr val="E5E7EB">
+                    <a:alpha val="62000"/>
+                  </a:srgbClr>
+                </a:solidFill>
+                <a:latin typeface="Aptos"/>
+                <a:ea typeface="Microsoft YaHei"/>
+              </a:rPr>
+              <a:t>Approval Cycle Time</a:t>
+            </a:r>
+          </a:p>
+          <a:p>
+            <a:pPr algn="ctr"/>
+            <a:r>
+              <a:rPr lang="zh-CN" sz="2700" b="1">
+                <a:solidFill>
+                  <a:srgbClr val="1F2937"/>
+                </a:solidFill>
+                <a:latin typeface="Aptos"/>
+                <a:ea typeface="Microsoft YaHei"/>
+              </a:rPr>
+              <a:t>-30%</a:t>
+            </a:r>
+          </a:p>
+          <a:p>
+            <a:pPr algn="ctr"/>
+            <a:r>
+              <a:rPr lang="zh-CN" sz="980">
+                <a:solidFill>
+                  <a:srgbClr val="E5E7EB">
+                    <a:alpha val="62000"/>
+                  </a:srgbClr>
+                </a:solidFill>
+                <a:latin typeface="Aptos"/>
+                <a:ea typeface="Microsoft YaHei"/>
+              </a:rPr>
+              <a:t>Pilot target</a:t>
+            </a:r>
+          </a:p>
+        </p:txBody>
+      </p:sp>
+      <p:sp>
+        <p:nvSpPr>
+          <p:cNvPr id="23" name="MetricBg1"/>
+          <p:cNvSpPr/>
+          <p:nvPr/>
+        </p:nvSpPr>
+        <p:spPr>
+          <a:xfrm>
+            <a:off x="4350000" y="1550000"/>
+            <a:ext cx="3500000" cy="1020000"/>
           </a:xfrm>
           <a:prstGeom prst="roundRect">
             <a:avLst>
-              <a:gd name="adj" fmla="val 4000"/>
+              <a:gd name="adj" fmla="val 5000"/>
             </a:avLst>
           </a:prstGeom>
           <a:solidFill>
@@ -2980,106 +2660,94 @@
               <a:alpha val="9000"/>
             </a:srgbClr>
           </a:solidFill>
-          <a:ln w="12700">
+          <a:ln w="9525">
             <a:solidFill>
               <a:srgbClr val="F97316">
-                <a:alpha val="12000"/>
+                <a:alpha val="18000"/>
               </a:srgbClr>
             </a:solidFill>
           </a:ln>
-          <a:effectLst>
-            <a:outerShdw blurRad="101600" dist="38100" dir="2700000" algn="bl" rotWithShape="0">
-              <a:srgbClr val="000000">
-                <a:alpha val="12000"/>
-              </a:srgbClr>
-            </a:outerShdw>
-          </a:effectLst>
-        </p:spPr>
-      </p:sp>
-      <p:sp>
-        <p:nvSpPr>
-          <p:cNvPr id="44" name="CompareSpotlightHeader2"/>
-          <p:cNvSpPr/>
-          <p:nvPr/>
-        </p:nvSpPr>
-        <p:spPr>
-          <a:xfrm>
-            <a:off x="7080000" y="1880000"/>
-            <a:ext cx="3040000" cy="420000"/>
-          </a:xfrm>
-          <a:prstGeom prst="rect">
-            <a:avLst/>
-          </a:prstGeom>
-        </p:spPr>
-        <p:txBody>
-          <a:bodyPr anchor="ctr">
-            <a:normAutofit/>
-          </a:bodyPr>
-          <a:lstStyle/>
-          <a:p>
-            <a:pPr algn="l"/>
-            <a:r>
-              <a:rPr lang="zh-CN" sz="1700" b="1">
-                <a:solidFill>
-                  <a:srgbClr val="F97316"/>
-                </a:solidFill>
-                <a:latin typeface="Aptos"/>
-                <a:ea typeface="Microsoft YaHei"/>
-              </a:rPr>
-              <a:t>Days 31-60: Accelerate</a:t>
-            </a:r>
-          </a:p>
-        </p:txBody>
-      </p:sp>
-      <p:sp>
-        <p:nvSpPr>
-          <p:cNvPr id="45" name="CompareSpotlightDetail2"/>
-          <p:cNvSpPr/>
-          <p:nvPr/>
-        </p:nvSpPr>
-        <p:spPr>
-          <a:xfrm>
-            <a:off x="7080000" y="2420000"/>
-            <a:ext cx="3040000" cy="550000"/>
-          </a:xfrm>
-          <a:prstGeom prst="rect">
-            <a:avLst/>
-          </a:prstGeom>
-        </p:spPr>
-        <p:txBody>
-          <a:bodyPr anchor="t" lIns="180000" rIns="180000">
-            <a:normAutofit/>
-          </a:bodyPr>
-          <a:lstStyle/>
-          <a:p>
-            <a:pPr algn="l"/>
-            <a:r>
-              <a:rPr lang="zh-CN" sz="1350">
-                <a:solidFill>
-                  <a:srgbClr val="E5E7EB"/>
-                </a:solidFill>
-                <a:latin typeface="Aptos"/>
-                <a:ea typeface="Microsoft YaHei"/>
-              </a:rPr>
-              <a:t>Owner: Marketing and Sales. Release public trial</a:t>
-            </a:r>
-          </a:p>
-        </p:txBody>
-      </p:sp>
-      <p:sp>
-        <p:nvSpPr>
-          <p:cNvPr id="46" name="CompareSpotlightPanel3"/>
-          <p:cNvSpPr/>
-          <p:nvPr/>
-        </p:nvSpPr>
-        <p:spPr>
-          <a:xfrm>
-            <a:off x="6900000" y="3350000"/>
-            <a:ext cx="3400000" cy="1450000"/>
+        </p:spPr>
+      </p:sp>
+      <p:sp>
+        <p:nvSpPr>
+          <p:cNvPr id="24" name="MetricText1"/>
+          <p:cNvSpPr/>
+          <p:nvPr/>
+        </p:nvSpPr>
+        <p:spPr>
+          <a:xfrm>
+            <a:off x="4350000" y="1550000"/>
+            <a:ext cx="3500000" cy="1020000"/>
+          </a:xfrm>
+          <a:prstGeom prst="rect">
+            <a:avLst/>
+          </a:prstGeom>
+        </p:spPr>
+        <p:txBody>
+          <a:bodyPr anchor="ctr" lIns="72000" tIns="100000" rIns="72000" bIns="60000">
+            <a:normAutofit/>
+          </a:bodyPr>
+          <a:lstStyle/>
+          <a:p>
+            <a:pPr algn="ctr"/>
+            <a:r>
+              <a:rPr lang="zh-CN" sz="1020">
+                <a:solidFill>
+                  <a:srgbClr val="E5E7EB">
+                    <a:alpha val="62000"/>
+                  </a:srgbClr>
+                </a:solidFill>
+                <a:latin typeface="Aptos"/>
+                <a:ea typeface="Microsoft YaHei"/>
+              </a:rPr>
+              <a:t>On-Time Task Rate</a:t>
+            </a:r>
+          </a:p>
+          <a:p>
+            <a:pPr algn="ctr"/>
+            <a:r>
+              <a:rPr lang="zh-CN" sz="2700" b="1">
+                <a:solidFill>
+                  <a:srgbClr val="1F2937"/>
+                </a:solidFill>
+                <a:latin typeface="Aptos"/>
+                <a:ea typeface="Microsoft YaHei"/>
+              </a:rPr>
+              <a:t>+15%</a:t>
+            </a:r>
+          </a:p>
+          <a:p>
+            <a:pPr algn="ctr"/>
+            <a:r>
+              <a:rPr lang="zh-CN" sz="980">
+                <a:solidFill>
+                  <a:srgbClr val="E5E7EB">
+                    <a:alpha val="62000"/>
+                  </a:srgbClr>
+                </a:solidFill>
+                <a:latin typeface="Aptos"/>
+                <a:ea typeface="Microsoft YaHei"/>
+              </a:rPr>
+              <a:t>Weekly tracking</a:t>
+            </a:r>
+          </a:p>
+        </p:txBody>
+      </p:sp>
+      <p:sp>
+        <p:nvSpPr>
+          <p:cNvPr id="26" name="MetricBg2"/>
+          <p:cNvSpPr/>
+          <p:nvPr/>
+        </p:nvSpPr>
+        <p:spPr>
+          <a:xfrm>
+            <a:off x="8000000" y="1550000"/>
+            <a:ext cx="3500000" cy="1020000"/>
           </a:xfrm>
           <a:prstGeom prst="roundRect">
             <a:avLst>
-              <a:gd name="adj" fmla="val 4000"/>
+              <a:gd name="adj" fmla="val 5000"/>
             </a:avLst>
           </a:prstGeom>
           <a:solidFill>
@@ -3087,95 +2755,137 @@
               <a:alpha val="9000"/>
             </a:srgbClr>
           </a:solidFill>
-          <a:ln w="12700">
+          <a:ln w="9525">
             <a:solidFill>
               <a:srgbClr val="F97316">
-                <a:alpha val="12000"/>
+                <a:alpha val="18000"/>
               </a:srgbClr>
             </a:solidFill>
           </a:ln>
-          <a:effectLst>
-            <a:outerShdw blurRad="101600" dist="38100" dir="2700000" algn="bl" rotWithShape="0">
-              <a:srgbClr val="000000">
-                <a:alpha val="12000"/>
-              </a:srgbClr>
-            </a:outerShdw>
-          </a:effectLst>
-        </p:spPr>
-      </p:sp>
-      <p:sp>
-        <p:nvSpPr>
-          <p:cNvPr id="47" name="CompareSpotlightHeader3"/>
-          <p:cNvSpPr/>
-          <p:nvPr/>
-        </p:nvSpPr>
-        <p:spPr>
-          <a:xfrm>
-            <a:off x="7080000" y="3530000"/>
-            <a:ext cx="3040000" cy="420000"/>
-          </a:xfrm>
-          <a:prstGeom prst="rect">
-            <a:avLst/>
-          </a:prstGeom>
-        </p:spPr>
-        <p:txBody>
-          <a:bodyPr anchor="ctr">
-            <a:normAutofit/>
-          </a:bodyPr>
-          <a:lstStyle/>
-          <a:p>
-            <a:pPr algn="l"/>
-            <a:r>
-              <a:rPr lang="zh-CN" sz="1700" b="1">
-                <a:solidFill>
-                  <a:srgbClr val="F97316"/>
-                </a:solidFill>
-                <a:latin typeface="Aptos"/>
-                <a:ea typeface="Microsoft YaHei"/>
-              </a:rPr>
-              <a:t>Days 61-90: Scale</a:t>
-            </a:r>
-          </a:p>
-        </p:txBody>
-      </p:sp>
-      <p:sp>
-        <p:nvSpPr>
-          <p:cNvPr id="48" name="CompareSpotlightDetail3"/>
-          <p:cNvSpPr/>
-          <p:nvPr/>
-        </p:nvSpPr>
-        <p:spPr>
-          <a:xfrm>
-            <a:off x="7080000" y="4070000"/>
-            <a:ext cx="3040000" cy="550000"/>
-          </a:xfrm>
-          <a:prstGeom prst="rect">
-            <a:avLst/>
-          </a:prstGeom>
-        </p:spPr>
-        <p:txBody>
-          <a:bodyPr anchor="t" lIns="180000" rIns="180000">
-            <a:normAutofit/>
-          </a:bodyPr>
-          <a:lstStyle/>
-          <a:p>
-            <a:pPr algn="l"/>
-            <a:r>
-              <a:rPr lang="zh-CN" sz="1350">
+        </p:spPr>
+      </p:sp>
+      <p:sp>
+        <p:nvSpPr>
+          <p:cNvPr id="27" name="MetricText2"/>
+          <p:cNvSpPr/>
+          <p:nvPr/>
+        </p:nvSpPr>
+        <p:spPr>
+          <a:xfrm>
+            <a:off x="8000000" y="1550000"/>
+            <a:ext cx="3500000" cy="1020000"/>
+          </a:xfrm>
+          <a:prstGeom prst="rect">
+            <a:avLst/>
+          </a:prstGeom>
+        </p:spPr>
+        <p:txBody>
+          <a:bodyPr anchor="ctr" lIns="72000" tIns="100000" rIns="72000" bIns="60000">
+            <a:normAutofit/>
+          </a:bodyPr>
+          <a:lstStyle/>
+          <a:p>
+            <a:pPr algn="ctr"/>
+            <a:r>
+              <a:rPr lang="zh-CN" sz="1020">
+                <a:solidFill>
+                  <a:srgbClr val="E5E7EB">
+                    <a:alpha val="62000"/>
+                  </a:srgbClr>
+                </a:solidFill>
+                <a:latin typeface="Aptos"/>
+                <a:ea typeface="Microsoft YaHei"/>
+              </a:rPr>
+              <a:t>Knowledge Reuse Rate</a:t>
+            </a:r>
+          </a:p>
+          <a:p>
+            <a:pPr algn="ctr"/>
+            <a:r>
+              <a:rPr lang="zh-CN" sz="2700" b="1">
+                <a:solidFill>
+                  <a:srgbClr val="1F2937"/>
+                </a:solidFill>
+                <a:latin typeface="Aptos"/>
+                <a:ea typeface="Microsoft YaHei"/>
+              </a:rPr>
+              <a:t>+25%</a:t>
+            </a:r>
+          </a:p>
+          <a:p>
+            <a:pPr algn="ctr"/>
+            <a:r>
+              <a:rPr lang="zh-CN" sz="980">
+                <a:solidFill>
+                  <a:srgbClr val="E5E7EB">
+                    <a:alpha val="62000"/>
+                  </a:srgbClr>
+                </a:solidFill>
+                <a:latin typeface="Aptos"/>
+                <a:ea typeface="Microsoft YaHei"/>
+              </a:rPr>
+              <a:t>Quarterly review</a:t>
+            </a:r>
+          </a:p>
+        </p:txBody>
+      </p:sp>
+      <p:sp>
+        <p:nvSpPr>
+          <p:cNvPr id="41" name="Points"/>
+          <p:cNvSpPr/>
+          <p:nvPr/>
+        </p:nvSpPr>
+        <p:spPr>
+          <a:xfrm>
+            <a:off x="700000" y="2870000"/>
+            <a:ext cx="10800000" cy="2500000"/>
+          </a:xfrm>
+          <a:prstGeom prst="rect">
+            <a:avLst/>
+          </a:prstGeom>
+        </p:spPr>
+        <p:txBody>
+          <a:bodyPr anchor="t">
+            <a:normAutofit/>
+          </a:bodyPr>
+          <a:lstStyle/>
+          <a:p>
+            <a:pPr marL="342900" indent="-342900" algn="l">
+              <a:buFont typeface="Arial"/>
+              <a:buChar char="●"/>
+            </a:pPr>
+            <a:r>
+              <a:rPr lang="zh-CN" sz="1480">
                 <a:solidFill>
                   <a:srgbClr val="E5E7EB"/>
                 </a:solidFill>
                 <a:latin typeface="Aptos"/>
                 <a:ea typeface="Microsoft YaHei"/>
               </a:rPr>
-              <a:t>Owner: Revenue and Customer Success.</a:t>
-            </a:r>
-          </a:p>
-        </p:txBody>
-      </p:sp>
-      <p:sp>
-        <p:nvSpPr>
-          <p:cNvPr id="120" name="FooterRule"/>
+              <a:t>Validate ROI first with approval.</a:t>
+            </a:r>
+          </a:p>
+          <a:p>
+            <a:pPr marL="342900" indent="-342900" algn="l">
+              <a:buFont typeface="Arial"/>
+              <a:buChar char="●"/>
+            </a:pPr>
+            <a:r>
+              <a:rPr lang="zh-CN" sz="1480">
+                <a:solidFill>
+                  <a:srgbClr val="E5E7EB"/>
+                </a:solidFill>
+                <a:latin typeface="Aptos"/>
+                <a:ea typeface="Microsoft YaHei"/>
+              </a:rPr>
+              <a:t>Decide whether to expand.</a:t>
+            </a:r>
+          </a:p>
+        </p:txBody>
+      </p:sp>
+      <p:sp>
+        <p:nvSpPr>
+          <p:cNvPr id="60" name="FooterRule"/>
           <p:cNvSpPr/>
           <p:nvPr/>
         </p:nvSpPr>
@@ -3198,7 +2908,7 @@
       </p:sp>
       <p:sp>
         <p:nvSpPr>
-          <p:cNvPr id="122" name="PageNumber"/>
+          <p:cNvPr id="62" name="PageNumber"/>
           <p:cNvSpPr/>
           <p:nvPr/>
         </p:nvSpPr>
@@ -3226,7 +2936,7 @@
                   </a:srgbClr>
                 </a:solidFill>
               </a:rPr>
-              <a:t>08/10</a:t>
+              <a:t>08/09</a:t>
             </a:r>
           </a:p>
         </p:txBody>
@@ -3291,7 +3001,7 @@
                 <a:latin typeface="Aptos"/>
                 <a:ea typeface="Microsoft YaHei"/>
               </a:rPr>
-              <a:t>90-Day Rollout Timeline</a:t>
+              <a:t>Recommendation</a:t>
             </a:r>
           </a:p>
         </p:txBody>
@@ -3328,48 +3038,29 @@
                 <a:latin typeface="Aptos"/>
                 <a:ea typeface="Microsoft YaHei"/>
               </a:rPr>
-              <a:t>The launch should sequence from proof and activation to scale.</a:t>
-            </a:r>
-          </a:p>
-        </p:txBody>
-      </p:sp>
-      <p:sp>
-        <p:nvSpPr>
-          <p:cNvPr id="20" name="TimelineAxis"/>
-          <p:cNvSpPr/>
-          <p:nvPr/>
-        </p:nvSpPr>
-        <p:spPr>
-          <a:xfrm>
-            <a:off x="1300000" y="3700000"/>
-            <a:ext cx="9600000" cy="0"/>
-          </a:xfrm>
-          <a:prstGeom prst="line">
-            <a:avLst/>
-          </a:prstGeom>
-          <a:ln w="19050">
-            <a:solidFill>
-              <a:srgbClr val="F97316"/>
-            </a:solidFill>
-          </a:ln>
-        </p:spPr>
-      </p:sp>
-      <p:sp>
-        <p:nvSpPr>
-          <p:cNvPr id="21" name="TimelineDot1"/>
-          <p:cNvSpPr/>
-          <p:nvPr/>
-        </p:nvSpPr>
-        <p:spPr>
-          <a:xfrm>
-            <a:off x="1140000" y="3540000"/>
-            <a:ext cx="320000" cy="320000"/>
-          </a:xfrm>
-          <a:prstGeom prst="ellipse">
+              <a:t>Approve one focused validation cycle before scaling the approach.</a:t>
+            </a:r>
+          </a:p>
+        </p:txBody>
+      </p:sp>
+      <p:sp>
+        <p:nvSpPr>
+          <p:cNvPr id="40" name="ClosingDecisionBanner"/>
+          <p:cNvSpPr/>
+          <p:nvPr/>
+        </p:nvSpPr>
+        <p:spPr>
+          <a:xfrm>
+            <a:off x="1200000" y="1950000"/>
+            <a:ext cx="9800000" cy="1280000"/>
+          </a:xfrm>
+          <a:prstGeom prst="rect">
             <a:avLst/>
           </a:prstGeom>
           <a:solidFill>
-            <a:srgbClr val="F97316"/>
+            <a:srgbClr val="111827">
+              <a:alpha val="96000"/>
+            </a:srgbClr>
           </a:solidFill>
           <a:ln>
             <a:noFill/>
@@ -3378,90 +3069,22 @@
       </p:sp>
       <p:sp>
         <p:nvSpPr>
-          <p:cNvPr id="22" name="TimelineHead1"/>
-          <p:cNvSpPr/>
-          <p:nvPr/>
-        </p:nvSpPr>
-        <p:spPr>
-          <a:xfrm>
-            <a:off x="100000" y="2700000"/>
-            <a:ext cx="2400000" cy="420000"/>
-          </a:xfrm>
-          <a:prstGeom prst="rect">
-            <a:avLst/>
-          </a:prstGeom>
-        </p:spPr>
-        <p:txBody>
-          <a:bodyPr anchor="ctr">
-            <a:normAutofit/>
-          </a:bodyPr>
-          <a:lstStyle/>
-          <a:p>
-            <a:pPr algn="ctr"/>
-            <a:r>
-              <a:rPr lang="zh-CN" sz="1500" b="1">
-                <a:solidFill>
-                  <a:srgbClr val="F97316"/>
-                </a:solidFill>
-                <a:latin typeface="Aptos"/>
-                <a:ea typeface="Microsoft YaHei"/>
-              </a:rPr>
-              <a:t>Days 1-30: Validate</a:t>
-            </a:r>
-          </a:p>
-        </p:txBody>
-      </p:sp>
-      <p:sp>
-        <p:nvSpPr>
-          <p:cNvPr id="23" name="TimelineDetail1"/>
-          <p:cNvSpPr/>
-          <p:nvPr/>
-        </p:nvSpPr>
-        <p:spPr>
-          <a:xfrm>
-            <a:off x="100000" y="4020000"/>
-            <a:ext cx="2400000" cy="1100000"/>
-          </a:xfrm>
-          <a:prstGeom prst="rect">
-            <a:avLst/>
-          </a:prstGeom>
-        </p:spPr>
-        <p:txBody>
-          <a:bodyPr anchor="t">
-            <a:normAutofit/>
-          </a:bodyPr>
-          <a:lstStyle/>
-          <a:p>
-            <a:pPr algn="l"/>
-            <a:r>
-              <a:rPr lang="zh-CN" sz="1300">
-                <a:solidFill>
-                  <a:srgbClr val="E5E7EB"/>
-                </a:solidFill>
-                <a:latin typeface="Aptos"/>
-                <a:ea typeface="Microsoft YaHei"/>
-              </a:rPr>
-              <a:t>Owner: Product and Growth. Launch beta onboarding</a:t>
-            </a:r>
-          </a:p>
-        </p:txBody>
-      </p:sp>
-      <p:sp>
-        <p:nvSpPr>
-          <p:cNvPr id="24" name="TimelineDot2"/>
-          <p:cNvSpPr/>
-          <p:nvPr/>
-        </p:nvSpPr>
-        <p:spPr>
-          <a:xfrm>
-            <a:off x="5940000" y="3540000"/>
-            <a:ext cx="320000" cy="320000"/>
-          </a:xfrm>
-          <a:prstGeom prst="ellipse">
+          <p:cNvPr id="41" name="ClosingDecisionAccent"/>
+          <p:cNvSpPr/>
+          <p:nvPr/>
+        </p:nvSpPr>
+        <p:spPr>
+          <a:xfrm>
+            <a:off x="1200000" y="1950000"/>
+            <a:ext cx="130000" cy="1280000"/>
+          </a:xfrm>
+          <a:prstGeom prst="rect">
             <a:avLst/>
           </a:prstGeom>
           <a:solidFill>
-            <a:srgbClr val="F97316"/>
+            <a:srgbClr val="F97316">
+              <a:alpha val="100000"/>
+            </a:srgbClr>
           </a:solidFill>
           <a:ln>
             <a:noFill/>
@@ -3470,14 +3093,14 @@
       </p:sp>
       <p:sp>
         <p:nvSpPr>
-          <p:cNvPr id="25" name="TimelineHead2"/>
-          <p:cNvSpPr/>
-          <p:nvPr/>
-        </p:nvSpPr>
-        <p:spPr>
-          <a:xfrm>
-            <a:off x="4900000" y="2700000"/>
-            <a:ext cx="2400000" cy="420000"/>
+          <p:cNvPr id="42" name="ClosingDecisionHeading"/>
+          <p:cNvSpPr/>
+          <p:nvPr/>
+        </p:nvSpPr>
+        <p:spPr>
+          <a:xfrm>
+            <a:off x="1500000" y="2180000"/>
+            <a:ext cx="9200000" cy="360000"/>
           </a:xfrm>
           <a:prstGeom prst="rect">
             <a:avLst/>
@@ -3489,30 +3112,100 @@
           </a:bodyPr>
           <a:lstStyle/>
           <a:p>
-            <a:pPr algn="ctr"/>
-            <a:r>
-              <a:rPr lang="zh-CN" sz="1500" b="1">
+            <a:pPr algn="l"/>
+            <a:r>
+              <a:rPr lang="zh-CN" sz="1700" b="1">
+                <a:solidFill>
+                  <a:srgbClr val="FFFFFF"/>
+                </a:solidFill>
+                <a:latin typeface="Aptos"/>
+                <a:ea typeface="Microsoft YaHei"/>
+              </a:rPr>
+              <a:t>Decision</a:t>
+            </a:r>
+          </a:p>
+        </p:txBody>
+      </p:sp>
+      <p:sp>
+        <p:nvSpPr>
+          <p:cNvPr id="43" name="ClosingDecisionText"/>
+          <p:cNvSpPr/>
+          <p:nvPr/>
+        </p:nvSpPr>
+        <p:spPr>
+          <a:xfrm>
+            <a:off x="1500000" y="2650000"/>
+            <a:ext cx="9200000" cy="380000"/>
+          </a:xfrm>
+          <a:prstGeom prst="rect">
+            <a:avLst/>
+          </a:prstGeom>
+        </p:spPr>
+        <p:txBody>
+          <a:bodyPr anchor="t">
+            <a:normAutofit/>
+          </a:bodyPr>
+          <a:lstStyle/>
+          <a:p>
+            <a:pPr algn="l"/>
+            <a:r>
+              <a:rPr lang="zh-CN" sz="1450">
+                <a:solidFill>
+                  <a:srgbClr val="E5E7EB"/>
+                </a:solidFill>
+                <a:latin typeface="Aptos"/>
+                <a:ea typeface="Microsoft YaHei"/>
+              </a:rPr>
+              <a:t>Run a scoped pilot against the most important deck workflow</a:t>
+            </a:r>
+          </a:p>
+        </p:txBody>
+      </p:sp>
+      <p:sp>
+        <p:nvSpPr>
+          <p:cNvPr id="50" name="ClosingDecisionSupportHead1"/>
+          <p:cNvSpPr/>
+          <p:nvPr/>
+        </p:nvSpPr>
+        <p:spPr>
+          <a:xfrm>
+            <a:off x="1500000" y="3720000"/>
+            <a:ext cx="3600000" cy="300000"/>
+          </a:xfrm>
+          <a:prstGeom prst="rect">
+            <a:avLst/>
+          </a:prstGeom>
+        </p:spPr>
+        <p:txBody>
+          <a:bodyPr anchor="ctr">
+            <a:normAutofit/>
+          </a:bodyPr>
+          <a:lstStyle/>
+          <a:p>
+            <a:pPr algn="l"/>
+            <a:r>
+              <a:rPr lang="zh-CN" sz="1350" b="1">
                 <a:solidFill>
                   <a:srgbClr val="F97316"/>
                 </a:solidFill>
                 <a:latin typeface="Aptos"/>
                 <a:ea typeface="Microsoft YaHei"/>
               </a:rPr>
-              <a:t>Days 31-60: Accelerate</a:t>
-            </a:r>
-          </a:p>
-        </p:txBody>
-      </p:sp>
-      <p:sp>
-        <p:nvSpPr>
-          <p:cNvPr id="26" name="TimelineDetail2"/>
-          <p:cNvSpPr/>
-          <p:nvPr/>
-        </p:nvSpPr>
-        <p:spPr>
-          <a:xfrm>
-            <a:off x="4900000" y="4020000"/>
-            <a:ext cx="2400000" cy="1100000"/>
+              <a:t>Quality Gate</a:t>
+            </a:r>
+          </a:p>
+        </p:txBody>
+      </p:sp>
+      <p:sp>
+        <p:nvSpPr>
+          <p:cNvPr id="51" name="ClosingDecisionSupportText1"/>
+          <p:cNvSpPr/>
+          <p:nvPr/>
+        </p:nvSpPr>
+        <p:spPr>
+          <a:xfrm>
+            <a:off x="1500000" y="4130000"/>
+            <a:ext cx="3600000" cy="420000"/>
           </a:xfrm>
           <a:prstGeom prst="rect">
             <a:avLst/>
@@ -3526,50 +3219,28 @@
           <a:p>
             <a:pPr algn="l"/>
             <a:r>
-              <a:rPr lang="zh-CN" sz="1300">
+              <a:rPr lang="zh-CN" sz="1200">
                 <a:solidFill>
                   <a:srgbClr val="E5E7EB"/>
                 </a:solidFill>
                 <a:latin typeface="Aptos"/>
                 <a:ea typeface="Microsoft YaHei"/>
               </a:rPr>
-              <a:t>Owner: Marketing and Sales. Release public trial</a:t>
-            </a:r>
-          </a:p>
-        </p:txBody>
-      </p:sp>
-      <p:sp>
-        <p:nvSpPr>
-          <p:cNvPr id="27" name="TimelineDot3"/>
-          <p:cNvSpPr/>
-          <p:nvPr/>
-        </p:nvSpPr>
-        <p:spPr>
-          <a:xfrm>
-            <a:off x="10740000" y="3540000"/>
-            <a:ext cx="320000" cy="320000"/>
-          </a:xfrm>
-          <a:prstGeom prst="ellipse">
-            <a:avLst/>
-          </a:prstGeom>
-          <a:solidFill>
-            <a:srgbClr val="F97316"/>
-          </a:solidFill>
-          <a:ln>
-            <a:noFill/>
-          </a:ln>
-        </p:spPr>
-      </p:sp>
-      <p:sp>
-        <p:nvSpPr>
-          <p:cNvPr id="28" name="TimelineHead3"/>
-          <p:cNvSpPr/>
-          <p:nvPr/>
-        </p:nvSpPr>
-        <p:spPr>
-          <a:xfrm>
-            <a:off x="9700000" y="2700000"/>
-            <a:ext cx="2400000" cy="420000"/>
+              <a:t>Require editable output, layout diversity, and contrast checks</a:t>
+            </a:r>
+          </a:p>
+        </p:txBody>
+      </p:sp>
+      <p:sp>
+        <p:nvSpPr>
+          <p:cNvPr id="52" name="ClosingDecisionSupportHead2"/>
+          <p:cNvSpPr/>
+          <p:nvPr/>
+        </p:nvSpPr>
+        <p:spPr>
+          <a:xfrm>
+            <a:off x="6050000" y="3720000"/>
+            <a:ext cx="3600000" cy="300000"/>
           </a:xfrm>
           <a:prstGeom prst="rect">
             <a:avLst/>
@@ -3581,30 +3252,30 @@
           </a:bodyPr>
           <a:lstStyle/>
           <a:p>
-            <a:pPr algn="ctr"/>
-            <a:r>
-              <a:rPr lang="zh-CN" sz="1500" b="1">
+            <a:pPr algn="l"/>
+            <a:r>
+              <a:rPr lang="zh-CN" sz="1350" b="1">
                 <a:solidFill>
                   <a:srgbClr val="F97316"/>
                 </a:solidFill>
                 <a:latin typeface="Aptos"/>
                 <a:ea typeface="Microsoft YaHei"/>
               </a:rPr>
-              <a:t>Days 61-90: Scale</a:t>
-            </a:r>
-          </a:p>
-        </p:txBody>
-      </p:sp>
-      <p:sp>
-        <p:nvSpPr>
-          <p:cNvPr id="29" name="TimelineDetail3"/>
-          <p:cNvSpPr/>
-          <p:nvPr/>
-        </p:nvSpPr>
-        <p:spPr>
-          <a:xfrm>
-            <a:off x="9700000" y="4020000"/>
-            <a:ext cx="2400000" cy="1100000"/>
+              <a:t>Next Step</a:t>
+            </a:r>
+          </a:p>
+        </p:txBody>
+      </p:sp>
+      <p:sp>
+        <p:nvSpPr>
+          <p:cNvPr id="53" name="ClosingDecisionSupportText2"/>
+          <p:cNvSpPr/>
+          <p:nvPr/>
+        </p:nvSpPr>
+        <p:spPr>
+          <a:xfrm>
+            <a:off x="6050000" y="4130000"/>
+            <a:ext cx="3600000" cy="420000"/>
           </a:xfrm>
           <a:prstGeom prst="rect">
             <a:avLst/>
@@ -3618,21 +3289,21 @@
           <a:p>
             <a:pPr algn="l"/>
             <a:r>
-              <a:rPr lang="zh-CN" sz="1300">
+              <a:rPr lang="zh-CN" sz="1200">
                 <a:solidFill>
                   <a:srgbClr val="E5E7EB"/>
                 </a:solidFill>
                 <a:latin typeface="Aptos"/>
                 <a:ea typeface="Microsoft YaHei"/>
               </a:rPr>
-              <a:t>Owner: Revenue and Customer Success.</a:t>
-            </a:r>
-          </a:p>
-        </p:txBody>
-      </p:sp>
-      <p:sp>
-        <p:nvSpPr>
-          <p:cNvPr id="140" name="FooterRule"/>
+              <a:t>Compare generated decks with a manual baseline before rollout</a:t>
+            </a:r>
+          </a:p>
+        </p:txBody>
+      </p:sp>
+      <p:sp>
+        <p:nvSpPr>
+          <p:cNvPr id="150" name="FooterRule"/>
           <p:cNvSpPr/>
           <p:nvPr/>
         </p:nvSpPr>
@@ -3655,7 +3326,7 @@
       </p:sp>
       <p:sp>
         <p:nvSpPr>
-          <p:cNvPr id="142" name="PageNumber"/>
+          <p:cNvPr id="152" name="PageNumber"/>
           <p:cNvSpPr/>
           <p:nvPr/>
         </p:nvSpPr>
@@ -3683,7 +3354,7 @@
                   </a:srgbClr>
                 </a:solidFill>
               </a:rPr>
-              <a:t>09/10</a:t>
+              <a:t>09/09</a:t>
             </a:r>
           </a:p>
         </p:txBody>

</xml_diff>